<commit_message>
docs: add real UI screenshots to deck, fix Hindi figures in report
Presentation
- slide 2: real staff dashboard screenshot
- slide 3: real video lesson player screenshot
- slide 7: real Gemini assessment builder screenshot
- slide 9: English/Hindi screenshot pair showing the same interface
  in both locales; bullets resized 28pt -> 20pt to prevent overlap

Report
- fig 5.15 now embeds the Hindi dashboard (was byte-identical English)
- fig 5.16 given its own media part for the Hindi course view
  (it previously reused the English course image from fig 5.3)
- removed a stray uncaptioned duplicate image after fig 5.16
- regenerate PDF (51 pages, A4)

Screenshots
- recapture 03-hindi/* via /language/toggle/?lang=hi; the earlier
  capture omitted the query param and defaulted to English
</commit_message>
<xml_diff>
--- a/docs/presentation/finalppt.pptx
+++ b/docs/presentation/finalppt.pptx
@@ -6650,7 +6650,7 @@
           <a:lstStyle/>
           <a:p>
             <a:r>
-              <a:rPr lang="en-US" sz="2800" dirty="0" smtClean="0">
+              <a:rPr lang="en-US" sz="2000" dirty="0" smtClean="0">
                 <a:latin typeface="Times New Roman" pitchFamily="18" charset="0"/>
                 <a:cs typeface="Times New Roman" pitchFamily="18" charset="0"/>
               </a:rPr>
@@ -6677,7 +6677,7 @@
           <a:lstStyle/>
           <a:p>
             <a:r>
-              <a:rPr lang="en-US" sz="2800" dirty="0" smtClean="0">
+              <a:rPr lang="en-US" sz="2000" dirty="0" smtClean="0">
                 <a:latin typeface="Times New Roman" pitchFamily="18" charset="0"/>
                 <a:cs typeface="Times New Roman" pitchFamily="18" charset="0"/>
               </a:rPr>
@@ -6686,7 +6686,7 @@
           </a:p>
           <a:p>
             <a:r>
-              <a:rPr lang="en-US" sz="2800" dirty="0" smtClean="0">
+              <a:rPr lang="en-US" sz="2000" dirty="0" smtClean="0">
                 <a:latin typeface="Times New Roman" pitchFamily="18" charset="0"/>
                 <a:cs typeface="Times New Roman" pitchFamily="18" charset="0"/>
               </a:rPr>
@@ -6695,7 +6695,7 @@
           </a:p>
           <a:p>
             <a:r>
-              <a:rPr lang="en-US" sz="2800" dirty="0" smtClean="0">
+              <a:rPr lang="en-US" sz="2000" dirty="0" smtClean="0">
                 <a:latin typeface="Times New Roman" pitchFamily="18" charset="0"/>
                 <a:cs typeface="Times New Roman" pitchFamily="18" charset="0"/>
               </a:rPr>
@@ -6704,7 +6704,7 @@
           </a:p>
           <a:p>
             <a:r>
-              <a:rPr lang="en-US" sz="2800" dirty="0" smtClean="0">
+              <a:rPr lang="en-US" sz="2000" dirty="0" smtClean="0">
                 <a:latin typeface="Times New Roman" pitchFamily="18" charset="0"/>
                 <a:cs typeface="Times New Roman" pitchFamily="18" charset="0"/>
               </a:rPr>
@@ -6713,13 +6713,13 @@
           </a:p>
           <a:p>
             <a:r>
-              <a:rPr lang="en-US" sz="2800" dirty="0" smtClean="0">
+              <a:rPr lang="en-US" sz="2000" dirty="0" smtClean="0">
                 <a:latin typeface="Times New Roman" pitchFamily="18" charset="0"/>
                 <a:cs typeface="Times New Roman" pitchFamily="18" charset="0"/>
               </a:rPr>
               <a:t>Generic administration.</a:t>
             </a:r>
-            <a:endParaRPr lang="en-US" sz="2800" dirty="0">
+            <a:endParaRPr lang="en-US" sz="2000" dirty="0">
               <a:latin typeface="Times New Roman" pitchFamily="18" charset="0"/>
               <a:cs typeface="Times New Roman" pitchFamily="18" charset="0"/>
             </a:endParaRPr>
@@ -6749,27 +6749,27 @@
           <a:lstStyle/>
           <a:p>
             <a:r>
-              <a:rPr lang="en-US" sz="2800" dirty="0" smtClean="0">
+              <a:rPr lang="en-US" sz="2000" dirty="0" smtClean="0">
                 <a:latin typeface="Times New Roman" pitchFamily="18" charset="0"/>
                 <a:cs typeface="Times New Roman" pitchFamily="18" charset="0"/>
               </a:rPr>
               <a:t>SRMS </a:t>
             </a:r>
             <a:r>
-              <a:rPr lang="en-US" sz="2800" dirty="0" err="1" smtClean="0">
+              <a:rPr lang="en-US" sz="2000" dirty="0" err="1" smtClean="0">
                 <a:latin typeface="Times New Roman" pitchFamily="18" charset="0"/>
                 <a:cs typeface="Times New Roman" pitchFamily="18" charset="0"/>
               </a:rPr>
               <a:t>Drona</a:t>
             </a:r>
             <a:r>
-              <a:rPr lang="en-US" sz="2800" dirty="0" smtClean="0">
+              <a:rPr lang="en-US" sz="2000" dirty="0" smtClean="0">
                 <a:latin typeface="Times New Roman" pitchFamily="18" charset="0"/>
                 <a:cs typeface="Times New Roman" pitchFamily="18" charset="0"/>
               </a:rPr>
               <a:t>:</a:t>
             </a:r>
-            <a:endParaRPr lang="en-US" sz="2800" dirty="0">
+            <a:endParaRPr lang="en-US" sz="2000" dirty="0">
               <a:latin typeface="Times New Roman" pitchFamily="18" charset="0"/>
               <a:cs typeface="Times New Roman" pitchFamily="18" charset="0"/>
             </a:endParaRPr>
@@ -6794,7 +6794,7 @@
           <a:lstStyle/>
           <a:p>
             <a:r>
-              <a:rPr lang="en-US" sz="2800" dirty="0" smtClean="0">
+              <a:rPr lang="en-US" sz="2000" dirty="0" smtClean="0">
                 <a:latin typeface="Times New Roman" pitchFamily="18" charset="0"/>
                 <a:cs typeface="Times New Roman" pitchFamily="18" charset="0"/>
               </a:rPr>
@@ -6803,7 +6803,7 @@
           </a:p>
           <a:p>
             <a:r>
-              <a:rPr lang="en-US" sz="2800" dirty="0" smtClean="0">
+              <a:rPr lang="en-US" sz="2000" dirty="0" smtClean="0">
                 <a:latin typeface="Times New Roman" pitchFamily="18" charset="0"/>
                 <a:cs typeface="Times New Roman" pitchFamily="18" charset="0"/>
               </a:rPr>
@@ -6812,7 +6812,7 @@
           </a:p>
           <a:p>
             <a:r>
-              <a:rPr lang="en-US" sz="2800" dirty="0" smtClean="0">
+              <a:rPr lang="en-US" sz="2000" dirty="0" smtClean="0">
                 <a:latin typeface="Times New Roman" pitchFamily="18" charset="0"/>
                 <a:cs typeface="Times New Roman" pitchFamily="18" charset="0"/>
               </a:rPr>
@@ -6821,7 +6821,7 @@
           </a:p>
           <a:p>
             <a:r>
-              <a:rPr lang="en-US" sz="2800" dirty="0" smtClean="0">
+              <a:rPr lang="en-US" sz="2000" dirty="0" smtClean="0">
                 <a:latin typeface="Times New Roman" pitchFamily="18" charset="0"/>
                 <a:cs typeface="Times New Roman" pitchFamily="18" charset="0"/>
               </a:rPr>
@@ -6830,16 +6830,128 @@
           </a:p>
           <a:p>
             <a:r>
-              <a:rPr lang="en-US" sz="2800" dirty="0" smtClean="0">
+              <a:rPr lang="en-US" sz="2000" dirty="0" smtClean="0">
                 <a:latin typeface="Times New Roman" pitchFamily="18" charset="0"/>
                 <a:cs typeface="Times New Roman" pitchFamily="18" charset="0"/>
               </a:rPr>
               <a:t>Role based administration.</a:t>
             </a:r>
-            <a:endParaRPr lang="en-US" sz="2800" dirty="0">
+            <a:endParaRPr lang="en-US" sz="2000" dirty="0">
               <a:latin typeface="Times New Roman" pitchFamily="18" charset="0"/>
               <a:cs typeface="Times New Roman" pitchFamily="18" charset="0"/>
             </a:endParaRPr>
+          </a:p>
+        </p:txBody>
+      </p:sp>
+      <p:pic>
+        <p:nvPicPr>
+          <p:cNvPr id="7" name="Screenshot English"/>
+          <p:cNvPicPr>
+            <a:picLocks noChangeAspect="1"/>
+          </p:cNvPicPr>
+          <p:nvPr/>
+        </p:nvPicPr>
+        <p:blipFill rotWithShape="1">
+          <a:blip r:embed="rId2"/>
+          <a:stretch>
+            <a:fillRect/>
+          </a:stretch>
+        </p:blipFill>
+        <p:spPr>
+          <a:xfrm>
+            <a:off x="1600000" y="4180000"/>
+            <a:ext cx="4100000" cy="2306000"/>
+          </a:xfrm>
+          <a:prstGeom prst="rect">
+            <a:avLst/>
+          </a:prstGeom>
+        </p:spPr>
+      </p:pic>
+      <p:pic>
+        <p:nvPicPr>
+          <p:cNvPr id="8" name="Screenshot Hindi"/>
+          <p:cNvPicPr>
+            <a:picLocks noChangeAspect="1"/>
+          </p:cNvPicPr>
+          <p:nvPr/>
+        </p:nvPicPr>
+        <p:blipFill rotWithShape="1">
+          <a:blip r:embed="rId3"/>
+          <a:stretch>
+            <a:fillRect/>
+          </a:stretch>
+        </p:blipFill>
+        <p:spPr>
+          <a:xfrm>
+            <a:off x="7100000" y="4180000"/>
+            <a:ext cx="4100000" cy="2306000"/>
+          </a:xfrm>
+          <a:prstGeom prst="rect">
+            <a:avLst/>
+          </a:prstGeom>
+        </p:spPr>
+      </p:pic>
+      <p:sp>
+        <p:nvSpPr>
+          <p:cNvPr id="9" name="Cap9"/>
+          <p:cNvSpPr txBox="1"/>
+          <p:nvPr/>
+        </p:nvSpPr>
+        <p:spPr>
+          <a:xfrm>
+            <a:off x="1500000" y="6500000"/>
+            <a:ext cx="5000000" cy="330000"/>
+          </a:xfrm>
+          <a:prstGeom prst="rect">
+            <a:avLst/>
+          </a:prstGeom>
+        </p:spPr>
+        <p:txBody>
+          <a:bodyPr wrap="square" anchor="t">
+            <a:normAutofit/>
+          </a:bodyPr>
+          <a:lstStyle/>
+          <a:p>
+            <a:pPr algn="ctr"/>
+            <a:r>
+              <a:rPr lang="en-US" sz="1400" b="1" dirty="0">
+                <a:latin typeface="Arial"/>
+                <a:cs typeface="Arial"/>
+              </a:rPr>
+              <a:t>Same interface — English</a:t>
+            </a:r>
+          </a:p>
+        </p:txBody>
+      </p:sp>
+      <p:sp>
+        <p:nvSpPr>
+          <p:cNvPr id="10" name="Cap10"/>
+          <p:cNvSpPr txBox="1"/>
+          <p:nvPr/>
+        </p:nvSpPr>
+        <p:spPr>
+          <a:xfrm>
+            <a:off x="7000000" y="6500000"/>
+            <a:ext cx="5000000" cy="330000"/>
+          </a:xfrm>
+          <a:prstGeom prst="rect">
+            <a:avLst/>
+          </a:prstGeom>
+        </p:spPr>
+        <p:txBody>
+          <a:bodyPr wrap="square" anchor="t">
+            <a:normAutofit/>
+          </a:bodyPr>
+          <a:lstStyle/>
+          <a:p>
+            <a:pPr algn="ctr"/>
+            <a:r>
+              <a:rPr lang="en-US" sz="1400" b="1" dirty="0">
+                <a:latin typeface="Arial"/>
+                <a:cs typeface="Arial"/>
+              </a:rPr>
+              <a:t>Same interface — हिन्दी</a:t>
+            </a:r>
           </a:p>
         </p:txBody>
       </p:sp>

</xml_diff>

<commit_message>
docs: keep one product screenshot per slide
Slide 9 previously carried an English/Hindi pair. Keep the Hindi
dashboard only, centred under the two columns so the slide reads as
balanced rather than weighted right, and reword the caption since
there is no longer a side-by-side to compare against:

  "Same interface - English" / "Same interface - Hindi"
  -> "Drona dashboard in Hindi - same tool, no separate build"

The Hindi view is the one that evidences the "Hindi + English" claim
in the SRMS Drona column. Slide rels and the unused English image
reference were dropped with it.
</commit_message>
<xml_diff>
--- a/docs/presentation/finalppt.pptx
+++ b/docs/presentation/finalppt.pptx
@@ -6845,30 +6845,6 @@
       </p:sp>
       <p:pic>
         <p:nvPicPr>
-          <p:cNvPr id="7" name="Screenshot English"/>
-          <p:cNvPicPr>
-            <a:picLocks noChangeAspect="1"/>
-          </p:cNvPicPr>
-          <p:nvPr/>
-        </p:nvPicPr>
-        <p:blipFill rotWithShape="1">
-          <a:blip r:embed="rId2"/>
-          <a:stretch>
-            <a:fillRect/>
-          </a:stretch>
-        </p:blipFill>
-        <p:spPr>
-          <a:xfrm>
-            <a:off x="1600000" y="4180000"/>
-            <a:ext cx="4100000" cy="2306000"/>
-          </a:xfrm>
-          <a:prstGeom prst="rect">
-            <a:avLst/>
-          </a:prstGeom>
-        </p:spPr>
-      </p:pic>
-      <p:pic>
-        <p:nvPicPr>
           <p:cNvPr id="8" name="Screenshot Hindi"/>
           <p:cNvPicPr>
             <a:picLocks noChangeAspect="1"/>
@@ -6883,8 +6859,8 @@
         </p:blipFill>
         <p:spPr>
           <a:xfrm>
-            <a:off x="7100000" y="4180000"/>
-            <a:ext cx="4100000" cy="2306000"/>
+            <a:off x="4112616" y="4133088"/>
+            <a:ext cx="3966464" cy="2231136"/>
           </a:xfrm>
           <a:prstGeom prst="rect">
             <a:avLst/>
@@ -6893,14 +6869,14 @@
       </p:pic>
       <p:sp>
         <p:nvSpPr>
-          <p:cNvPr id="9" name="Cap9"/>
+          <p:cNvPr id="10" name="Cap10"/>
           <p:cNvSpPr txBox="1"/>
           <p:nvPr/>
         </p:nvSpPr>
         <p:spPr>
           <a:xfrm>
-            <a:off x="1500000" y="6500000"/>
-            <a:ext cx="5000000" cy="330000"/>
+            <a:off x="2712568" y="6446520"/>
+            <a:ext cx="6766560" cy="310896"/>
           </a:xfrm>
           <a:prstGeom prst="rect">
             <a:avLst/>
@@ -6918,39 +6894,7 @@
                 <a:latin typeface="Arial"/>
                 <a:cs typeface="Arial"/>
               </a:rPr>
-              <a:t>Same interface — English</a:t>
-            </a:r>
-          </a:p>
-        </p:txBody>
-      </p:sp>
-      <p:sp>
-        <p:nvSpPr>
-          <p:cNvPr id="10" name="Cap10"/>
-          <p:cNvSpPr txBox="1"/>
-          <p:nvPr/>
-        </p:nvSpPr>
-        <p:spPr>
-          <a:xfrm>
-            <a:off x="7000000" y="6500000"/>
-            <a:ext cx="5000000" cy="330000"/>
-          </a:xfrm>
-          <a:prstGeom prst="rect">
-            <a:avLst/>
-          </a:prstGeom>
-        </p:spPr>
-        <p:txBody>
-          <a:bodyPr wrap="square" anchor="t">
-            <a:normAutofit/>
-          </a:bodyPr>
-          <a:lstStyle/>
-          <a:p>
-            <a:pPr algn="ctr"/>
-            <a:r>
-              <a:rPr lang="en-US" sz="1400" b="1" dirty="0">
-                <a:latin typeface="Arial"/>
-                <a:cs typeface="Arial"/>
-              </a:rPr>
-              <a:t>Same interface — हिन्दी</a:t>
+              <a:t>Drona dashboard in हिन्दी — same tool, no separate build</a:t>
             </a:r>
           </a:p>
         </p:txBody>

</xml_diff>